<commit_message>
Say "the senior" in the deck, not "she"
The deck borrowed "she" from the test persona. On a slide nobody knows who
she is, and the product is not only for women.

Co-Authored-By: Claude Opus 5.5 <noreply@anthropic.com>
</commit_message>
<xml_diff>
--- a/docs/demo/kataribe-pitch-deck.pptx
+++ b/docs/demo/kataribe-pitch-deck.pptx
@@ -8805,7 +8805,7 @@
                 <a:cs typeface="Google Sans Flex"/>
                 <a:sym typeface="Google Sans Flex"/>
               </a:rPr>
-              <a:t>A story extracted from a live session: life stage, people, places, and her quote matched to the turn it came from.</a:t>
+              <a:t>A story extracted from a live session: life stage, people, places, and the quote matched to the turn it came from.</a:t>
             </a:r>
           </a:p>
         </p:txBody>
@@ -8903,7 +8903,7 @@
                 <a:cs typeface="Google Sans Flex"/>
                 <a:sym typeface="Google Sans Flex"/>
               </a:rPr>
-              <a:t>Her granddaughter's question, the story that answers it, and her own words, one tap from her voice.</a:t>
+              <a:t>A granddaughter's question, the story that answers it, and the senior's own words, one tap from the audio.</a:t>
             </a:r>
           </a:p>
         </p:txBody>
@@ -10425,7 +10425,7 @@
                 <a:cs typeface="Google Sans Flex"/>
                 <a:sym typeface="Google Sans Flex"/>
               </a:rPr>
-              <a:t>Family questions about a topic she refused, the war and the evacuation, were held back; the rest went through. 3 of 3.</a:t>
+              <a:t>Family questions about a topic the senior refused, the war and the evacuation, were held back; the rest went through. 3 of 3.</a:t>
             </a:r>
           </a:p>
           <a:p>
@@ -10796,7 +10796,7 @@
                 <a:cs typeface="Google Sans Flex"/>
                 <a:sym typeface="Google Sans Flex"/>
               </a:rPr>
-              <a:t>It notices her sitting nearby, so there is no button at all</a:t>
+              <a:t>It notices the senior sitting nearby, so there is no button at all</a:t>
             </a:r>
           </a:p>
           <a:p>
@@ -11254,7 +11254,7 @@
                 <a:cs typeface="Google Sans Flex"/>
                 <a:sym typeface="Google Sans Flex"/>
               </a:rPr>
-              <a:t>Sharing with whoever she chooses: a friend, a care worker, a local archive</a:t>
+              <a:t>Sharing with whoever the senior chooses: a friend, a care worker, a local archive</a:t>
             </a:r>
           </a:p>
           <a:p>
@@ -11320,7 +11320,7 @@
                 <a:cs typeface="Google Sans Flex"/>
                 <a:sym typeface="Google Sans Flex"/>
               </a:rPr>
-              <a:t>A printed book of her stories</a:t>
+              <a:t>A printed book of the stories</a:t>
             </a:r>
           </a:p>
         </p:txBody>
@@ -12062,7 +12062,7 @@
       </p:sp>
       <p:sp>
         <p:nvSpPr>
-          <p:cNvPr id="167" name="For her"/>
+          <p:cNvPr id="167" name="For the senior"/>
           <p:cNvSpPr/>
           <p:nvPr/>
         </p:nvSpPr>
@@ -12146,7 +12146,7 @@
       </p:pic>
       <p:sp>
         <p:nvSpPr>
-          <p:cNvPr id="170" name="For her text"/>
+          <p:cNvPr id="170" name="For the senior text"/>
           <p:cNvSpPr txBox="1"/>
           <p:nvPr/>
         </p:nvSpPr>
@@ -12185,7 +12185,7 @@
                 <a:cs typeface="Google Sans Flex SemiBold"/>
                 <a:sym typeface="Google Sans Flex SemiBold"/>
               </a:rPr>
-              <a:t>For her</a:t>
+              <a:t>For the senior</a:t>
             </a:r>
           </a:p>
           <a:p>
@@ -12284,14 +12284,14 @@
                 <a:cs typeface="Google Sans Flex"/>
                 <a:sym typeface="Google Sans Flex"/>
               </a:rPr>
-              <a:t>A life story that lasts, in her own words</a:t>
-            </a:r>
-          </a:p>
-        </p:txBody>
-      </p:sp>
-      <p:sp>
-        <p:nvSpPr>
-          <p:cNvPr id="171" name="For her family"/>
+              <a:t>A life story that lasts, in their own words</a:t>
+            </a:r>
+          </a:p>
+        </p:txBody>
+      </p:sp>
+      <p:sp>
+        <p:nvSpPr>
+          <p:cNvPr id="171" name="For the family"/>
           <p:cNvSpPr/>
           <p:nvPr/>
         </p:nvSpPr>
@@ -12375,7 +12375,7 @@
       </p:pic>
       <p:sp>
         <p:nvSpPr>
-          <p:cNvPr id="174" name="For her family text"/>
+          <p:cNvPr id="174" name="For the family text"/>
           <p:cNvSpPr txBox="1"/>
           <p:nvPr/>
         </p:nvSpPr>
@@ -12414,7 +12414,7 @@
                 <a:cs typeface="Google Sans Flex SemiBold"/>
                 <a:sym typeface="Google Sans Flex SemiBold"/>
               </a:rPr>
-              <a:t>For her family</a:t>
+              <a:t>For the family</a:t>
             </a:r>
           </a:p>
           <a:p>
@@ -12480,7 +12480,7 @@
                 <a:cs typeface="Google Sans Flex"/>
                 <a:sym typeface="Google Sans Flex"/>
               </a:rPr>
-              <a:t>Her voice behind every quote</a:t>
+              <a:t>The original voice behind every quote</a:t>
             </a:r>
           </a:p>
           <a:p>
@@ -14384,7 +14384,7 @@
                 <a:cs typeface="Google Sans Flex"/>
                 <a:sym typeface="Google Sans Flex"/>
               </a:rPr>
-              <a:t>Relatives read what she shared, hear her voice, and send questions she is asked next time.</a:t>
+              <a:t>Relatives read what the senior shared, hear their voice, and send questions for next time.</a:t>
             </a:r>
           </a:p>
         </p:txBody>
@@ -14497,7 +14497,7 @@
                 <a:cs typeface="Google Sans Flex"/>
                 <a:sym typeface="Google Sans Flex"/>
               </a:rPr>
-              <a:t>She decides what is shared. Consent is kept as her own words, checked against the recording.</a:t>
+              <a:t>The senior decides what is shared. Consent is kept in their own words, checked against the recording.</a:t>
             </a:r>
           </a:p>
           <a:p>
@@ -14530,7 +14530,7 @@
                 <a:cs typeface="Google Sans Flex"/>
                 <a:sym typeface="Google Sans Flex"/>
               </a:rPr>
-              <a:t>Faithful, not rewritten. Every quote is verified word for word and plays in her own voice.</a:t>
+              <a:t>Faithful, not rewritten. Every quote is verified word for word and plays in the senior's own voice.</a:t>
             </a:r>
           </a:p>
           <a:p>
@@ -14563,7 +14563,7 @@
                 <a:cs typeface="Google Sans Flex"/>
                 <a:sym typeface="Google Sans Flex"/>
               </a:rPr>
-              <a:t>Built for Japanese: honorific register, names spelled from her profile, patience for long pauses.</a:t>
+              <a:t>Built for Japanese: honorific register, names spelled from the profile, patience for long pauses.</a:t>
             </a:r>
           </a:p>
         </p:txBody>
@@ -15674,7 +15674,7 @@
                 <a:cs typeface="Google Sans Flex"/>
                 <a:sym typeface="Google Sans Flex"/>
               </a:rPr>
-              <a:t>Shared only if she said yes, in words found in the recording. Private by default.</a:t>
+              <a:t>Shared only after a yes, in words found in the recording. Private by default.</a:t>
             </a:r>
           </a:p>
         </p:txBody>
@@ -15804,7 +15804,7 @@
                 <a:cs typeface="Google Sans Flex SemiBold"/>
                 <a:sym typeface="Google Sans Flex SemiBold"/>
               </a:rPr>
-              <a:t>Family page, her voice</a:t>
+              <a:t>Family page, real voice</a:t>
             </a:r>
           </a:p>
           <a:p>
@@ -15830,7 +15830,7 @@
                 <a:cs typeface="Google Sans Flex"/>
                 <a:sym typeface="Google Sans Flex"/>
               </a:rPr>
-              <a:t>Chapters by life stage. Every quote plays as a clip of her own answer.</a:t>
+              <a:t>Chapters by life stage. Every quote plays as a clip of the original answer.</a:t>
             </a:r>
           </a:p>
         </p:txBody>
@@ -16315,7 +16315,7 @@
                 <a:cs typeface="Google Sans Flex"/>
                 <a:sym typeface="Google Sans Flex"/>
               </a:rPr>
-              <a:t>5–10 min in Japanese with Gemini Live. She leads, it follows.</a:t>
+              <a:t>5–10 min in Japanese with Gemini Live. The senior leads, the AI follows.</a:t>
             </a:r>
           </a:p>
         </p:txBody>
@@ -17241,7 +17241,7 @@
                 <a:cs typeface="Google Sans Flex"/>
                 <a:sym typeface="Google Sans Flex"/>
               </a:rPr>
-              <a:t>Only stories she agreed to share, each quote in her voice.</a:t>
+              <a:t>Only stories the senior agreed to share, each with its audio.</a:t>
             </a:r>
           </a:p>
         </p:txBody>
@@ -17553,7 +17553,7 @@
                 <a:cs typeface="Google Sans Flex"/>
                 <a:sym typeface="Google Sans Flex"/>
               </a:rPr>
-              <a:t>A question touching a topic she refused is quietly held back.</a:t>
+              <a:t>A question touching a refused topic is quietly held back.</a:t>
             </a:r>
           </a:p>
         </p:txBody>
@@ -17819,7 +17819,7 @@
                 <a:cs typeface="Google Sans Flex Medium"/>
                 <a:sym typeface="Google Sans Flex Medium"/>
               </a:rPr>
-              <a:t>only what she shared</a:t>
+              <a:t>only what was shared</a:t>
             </a:r>
           </a:p>
         </p:txBody>
@@ -19068,7 +19068,7 @@
                 <a:cs typeface="Google Sans Flex"/>
                 <a:sym typeface="Google Sans Flex"/>
               </a:rPr>
-              <a:t>Greets her by name</a:t>
+              <a:t>Greets the senior by name</a:t>
             </a:r>
           </a:p>
         </p:txBody>
@@ -20179,7 +20179,7 @@
                 <a:cs typeface="Google Sans Flex"/>
                 <a:sym typeface="Google Sans Flex"/>
               </a:rPr>
-              <a:t>Her stories as chapters, by life stage</a:t>
+              <a:t>The senior's stories as chapters, by life stage</a:t>
             </a:r>
           </a:p>
         </p:txBody>
@@ -20279,7 +20279,7 @@
                 <a:cs typeface="Google Sans Flex"/>
                 <a:sym typeface="Google Sans Flex"/>
               </a:rPr>
-              <a:t>Her own words, and a clip of her answer to play</a:t>
+              <a:t>Their own words, with a clip of the answer to play</a:t>
             </a:r>
           </a:p>
         </p:txBody>
@@ -20379,7 +20379,7 @@
                 <a:cs typeface="Google Sans Flex"/>
                 <a:sym typeface="Google Sans Flex"/>
               </a:rPr>
-              <a:t>Ask her something; she hears who is asking</a:t>
+              <a:t>Ask a question; the senior hears who is asking</a:t>
             </a:r>
           </a:p>
         </p:txBody>
@@ -20811,7 +20811,7 @@
                 <a:cs typeface="Google Sans Flex"/>
                 <a:sym typeface="Google Sans Flex"/>
               </a:rPr>
-              <a:t>Records the talk in stereo: her voice left, the AI right</a:t>
+              <a:t>Records the talk in stereo: the senior left, the AI right</a:t>
             </a:r>
           </a:p>
           <a:p>
@@ -20993,7 +20993,7 @@
                 <a:cs typeface="Google Sans Flex"/>
                 <a:sym typeface="Google Sans Flex"/>
               </a:rPr>
-              <a:t>The family page: shared stories, her voice</a:t>
+              <a:t>The family page: shared stories, with audio</a:t>
             </a:r>
           </a:p>
         </p:txBody>
@@ -21271,7 +21271,7 @@
                 <a:cs typeface="Google Sans Flex"/>
                 <a:sym typeface="Google Sans Flex"/>
               </a:rPr>
-              <a:t>Her story so far and family questions, locked into a short-lived Live token</a:t>
+              <a:t>The story so far and family questions, locked into a short-lived Live token</a:t>
             </a:r>
           </a:p>
         </p:txBody>
@@ -21733,7 +21733,7 @@
                 <a:cs typeface="Google Sans Flex"/>
                 <a:sym typeface="Google Sans Flex"/>
               </a:rPr>
-              <a:t>Shared stories only; clips cut from her own channel</a:t>
+              <a:t>Shared stories only; clips cut from the senior's channel</a:t>
             </a:r>
           </a:p>
         </p:txBody>
@@ -23797,7 +23797,7 @@
                 <a:cs typeface="Google Sans Flex"/>
                 <a:sym typeface="Google Sans Flex"/>
               </a:rPr>
-              <a:t>The model never speaks for her. Gemini extracts the stories; plain code then checks every quote, and every yes to sharing, against the transcript.</a:t>
+              <a:t>The model never speaks for the senior. Gemini extracts the stories; plain code then checks every quote, and every yes to sharing, against the transcript.</a:t>
             </a:r>
           </a:p>
         </p:txBody>

</xml_diff>

<commit_message>
Give the deck's Japanese an English reading
The memoir service and the companion app are named as well as written in
Japanese (Oya no Zasshi; Cotomo, by Starley), the family question example is
granddaughter Yuka, and the test persona is Tanaka Haru. The family page in the
screens slide now shows Childhood and "Born in 1947", as the page itself does.

The senior's tablet on that slide stays in Japanese: it is the product, and
each part is explained beside it.

Co-Authored-By: Claude Opus 5.5 <noreply@anthropic.com>
</commit_message>
<xml_diff>
--- a/docs/demo/kataribe-pitch-deck.pptx
+++ b/docs/demo/kataribe-pitch-deck.pptx
@@ -8949,7 +8949,7 @@
                 <a:cs typeface="Google Sans Flex"/>
                 <a:sym typeface="Google Sans Flex"/>
               </a:rPr>
-              <a:t>Test persona 田中ハル, voiced by synthesized speech</a:t>
+              <a:t>Persona 田中ハル (Tanaka Haru), synthesized voice</a:t>
             </a:r>
           </a:p>
         </p:txBody>
@@ -13805,7 +13805,7 @@
                 <a:cs typeface="Google Sans Flex"/>
                 <a:sym typeface="Google Sans Flex"/>
               </a:rPr>
-              <a:t>親の雑誌 (Kokoromi), price incl. tax</a:t>
+              <a:t>Oya no Zasshi (親の雑誌, Kokoromi), price incl. tax</a:t>
             </a:r>
           </a:p>
         </p:txBody>
@@ -14172,7 +14172,7 @@
                 <a:cs typeface="Google Sans Flex"/>
                 <a:sym typeface="Google Sans Flex"/>
               </a:rPr>
-              <a:t>Companion AIs (茶の間 Cotomo) keep seniors company, but no life story comes out.</a:t>
+              <a:t>Companion AIs (Cotomo, by Starley) keep seniors company, but no life story comes out.</a:t>
             </a:r>
           </a:p>
           <a:p>
@@ -17397,7 +17397,7 @@
                 <a:cs typeface="Google Sans Flex"/>
                 <a:sym typeface="Google Sans Flex"/>
               </a:rPr>
-              <a:t>A relative writes a question and who they are: 孫のゆか.</a:t>
+              <a:t>A relative writes a question, and who they are: granddaughter Yuka.</a:t>
             </a:r>
           </a:p>
         </p:txBody>
@@ -19490,7 +19490,7 @@
                 <a:cs typeface="Google Sans Flex"/>
                 <a:sym typeface="Google Sans Flex"/>
               </a:rPr>
-              <a:t>1947年生まれ · 長野</a:t>
+              <a:t>Born in 1947 · 長野</a:t>
             </a:r>
           </a:p>
         </p:txBody>
@@ -19536,7 +19536,7 @@
                 <a:cs typeface="Google Sans Flex Medium"/>
                 <a:sym typeface="Google Sans Flex Medium"/>
               </a:rPr>
-              <a:t>子供時代</a:t>
+              <a:t>Childhood</a:t>
             </a:r>
           </a:p>
         </p:txBody>

</xml_diff>

<commit_message>
Run the live eval by hand rather than every night
It streams real Japanese audio at the Gemini API for tens of minutes a run.
With the credit spent it failed every night from Oct 10 and caught nothing;
topped up, it would spend credit every night of judging, when nothing
changes. The schedule is gone and the button kept: Actions, Eval, Run
workflow, after topping up, after a change to how the interviewer speaks or
listens, and before the submission. The README, the deploy notes, the
roadmap and the pitch deck no longer say nightly; the deck is rebuilt from
build.py.

Co-Authored-By: Claude Opus 5.5 <noreply@anthropic.com>
</commit_message>
<xml_diff>
--- a/docs/demo/kataribe-pitch-deck.pptx
+++ b/docs/demo/kataribe-pitch-deck.pptx
@@ -9536,7 +9536,7 @@
                 <a:cs typeface="Google Sans Flex"/>
                 <a:sym typeface="Google Sans Flex"/>
               </a:rPr>
-              <a:t>A browser session with no drop, 34 transcript entries. Run every night</a:t>
+              <a:t>A browser session with no drop, 34 transcript entries. Run with every live eval</a:t>
             </a:r>
           </a:p>
         </p:txBody>
@@ -23705,7 +23705,7 @@
                 <a:cs typeface="Google Sans Flex"/>
                 <a:sym typeface="Google Sans Flex"/>
               </a:rPr>
-              <a:t>GitHub Actions: checks on every push, the live eval nightly</a:t>
+              <a:t>GitHub Actions: checks on every push, the live eval on demand</a:t>
             </a:r>
           </a:p>
         </p:txBody>

</xml_diff>

<commit_message>
Bring the deck up to the demo video
- Links: the video, youtu.be/wg3SdraT2Oo, in place of TBD, and a QR code for
  it beside the live site's and the repository's.
- The mock-ups show Setsuko, with her real lines, in place of the stand-in
  example; the phone snapshots are her live page: the start page, her Gujo
  Odori story with its quote, and her family's two questions.
- No more "until the demo take": the snapshots' note says the family page is
  the demo's, and the native speaker's review of the Japanese is still next.
- pitch-deck.md points at the submitted deck, and its demo slide at the video.

Co-Authored-By: Claude Opus 5.5 <noreply@anthropic.com>
</commit_message>
<xml_diff>
--- a/docs/demo/kataribe-pitch-deck.pptx
+++ b/docs/demo/kataribe-pitch-deck.pptx
@@ -9077,7 +9077,7 @@
                 <a:cs typeface="Google Sans Flex"/>
                 <a:sym typeface="Google Sans Flex"/>
               </a:rPr>
-              <a:t>Live at kataribe.kaseovo.com, on a phone. The example persona stands in until the demo take.</a:t>
+              <a:t>Live at kataribe.kaseovo.com, on a phone: the demo's family page, written from the video's conversations.</a:t>
             </a:r>
           </a:p>
         </p:txBody>
@@ -10586,7 +10586,7 @@
                 <a:cs typeface="Google Sans Flex"/>
                 <a:sym typeface="Google Sans Flex"/>
               </a:rPr>
-              <a:t>Not yet measured: elderly voices and dialect. A native speaker reviews with the demo take.</a:t>
+              <a:t>Not yet measured: elderly voices and dialect. A native speaker's review of the Japanese is next.</a:t>
             </a:r>
           </a:p>
         </p:txBody>
@@ -11827,14 +11827,15 @@
             <a:r>
               <a:rPr lang="en-GB" sz="1400" dirty="0">
                 <a:solidFill>
-                  <a:srgbClr val="C5221F"/>
-                </a:solidFill>
-                <a:latin typeface="Google Sans Flex SemiBold"/>
+                  <a:srgbClr val="A0561B"/>
+                </a:solidFill>
+                <a:latin typeface="Google Sans Flex Medium"/>
                 <a:ea typeface="Hiragino Sans"/>
-                <a:cs typeface="Google Sans Flex SemiBold"/>
-                <a:sym typeface="Google Sans Flex SemiBold"/>
-              </a:rPr>
-              <a:t>TBD</a:t>
+                <a:cs typeface="Google Sans Flex Medium"/>
+                <a:sym typeface="Google Sans Flex Medium"/>
+                <a:hlinkClick r:id="rId6"/>
+              </a:rPr>
+              <a:t>youtu.be/wg3SdraT2Oo</a:t>
             </a:r>
             <a:endParaRPr>
               <a:latin typeface="Google Sans Flex Medium"/>
@@ -11885,7 +11886,7 @@
                 <a:ea typeface="Hiragino Sans"/>
                 <a:cs typeface="Google Sans Flex Medium"/>
                 <a:sym typeface="Google Sans Flex Medium"/>
-                <a:hlinkClick r:id="rId6"/>
+                <a:hlinkClick r:id="rId7"/>
               </a:rPr>
               <a:t>kataribe.kaseovo.com</a:t>
             </a:r>
@@ -11920,103 +11921,7 @@
       </p:sp>
       <p:pic>
         <p:nvPicPr>
-          <p:cNvPr id="160" name="Picture 159" descr="qr-product.png"/>
-          <p:cNvPicPr>
-            <a:picLocks noChangeAspect="1"/>
-          </p:cNvPicPr>
-          <p:nvPr/>
-        </p:nvPicPr>
-        <p:blipFill>
-          <a:blip r:embed="rId7"/>
-          <a:stretch>
-            <a:fillRect/>
-          </a:stretch>
-        </p:blipFill>
-        <p:spPr>
-          <a:xfrm>
-            <a:off x="448056" y="2606040"/>
-            <a:ext cx="1325880" cy="1325880"/>
-          </a:xfrm>
-          <a:prstGeom prst="rect">
-            <a:avLst/>
-          </a:prstGeom>
-        </p:spPr>
-      </p:pic>
-      <p:sp>
-        <p:nvSpPr>
-          <p:cNvPr id="161" name="Try it on your own life note"/>
-          <p:cNvSpPr txBox="1"/>
-          <p:nvPr/>
-        </p:nvSpPr>
-        <p:spPr>
-          <a:xfrm>
-            <a:off x="1956816" y="2606040"/>
-            <a:ext cx="2514600" cy="1325880"/>
-          </a:xfrm>
-          <a:prstGeom prst="rect">
-            <a:avLst/>
-          </a:prstGeom>
-          <a:noFill/>
-        </p:spPr>
-        <p:txBody>
-          <a:bodyPr wrap="square" lIns="0" tIns="0" rIns="0" bIns="0" anchor="ctr">
-            <a:noAutofit/>
-          </a:bodyPr>
-          <a:lstStyle/>
-          <a:p>
-            <a:pPr algn="l" marL="0" indent="0">
-              <a:spcBef>
-                <a:spcPts val="0"/>
-              </a:spcBef>
-              <a:spcAft>
-                <a:spcPts val="400"/>
-              </a:spcAft>
-              <a:buNone/>
-            </a:pPr>
-            <a:r>
-              <a:rPr lang="en-GB" sz="1200" dirty="0">
-                <a:solidFill>
-                  <a:srgbClr val="202124"/>
-                </a:solidFill>
-                <a:latin typeface="Google Sans Flex SemiBold"/>
-                <a:ea typeface="Hiragino Sans"/>
-                <a:cs typeface="Google Sans Flex SemiBold"/>
-                <a:sym typeface="Google Sans Flex SemiBold"/>
-              </a:rPr>
-              <a:t>Try it on your own life</a:t>
-            </a:r>
-          </a:p>
-          <a:p>
-            <a:pPr algn="l" marL="0" indent="0">
-              <a:lnSpc>
-                <a:spcPct val="105000"/>
-              </a:lnSpc>
-              <a:spcBef>
-                <a:spcPts val="0"/>
-              </a:spcBef>
-              <a:spcAft>
-                <a:spcPts val="0"/>
-              </a:spcAft>
-              <a:buNone/>
-            </a:pPr>
-            <a:r>
-              <a:rPr lang="en-GB" sz="1000" dirty="0">
-                <a:solidFill>
-                  <a:srgbClr val="5F6368"/>
-                </a:solidFill>
-                <a:latin typeface="Google Sans Flex"/>
-                <a:ea typeface="Hiragino Sans"/>
-                <a:cs typeface="Google Sans Flex"/>
-                <a:sym typeface="Google Sans Flex"/>
-              </a:rPr>
-              <a:t>A family page from the demo, then a conversation of your own, in English. About three minutes.</a:t>
-            </a:r>
-          </a:p>
-        </p:txBody>
-      </p:sp>
-      <p:pic>
-        <p:nvPicPr>
-          <p:cNvPr id="162" name="Picture 161" descr="qr-repo.png"/>
+          <p:cNvPr id="160" name="Picture 159" descr="qr-video.png"/>
           <p:cNvPicPr>
             <a:picLocks noChangeAspect="1"/>
           </p:cNvPicPr>
@@ -12030,8 +11935,8 @@
         </p:blipFill>
         <p:spPr>
           <a:xfrm>
-            <a:off x="4700016" y="2606040"/>
-            <a:ext cx="1325880" cy="1325880"/>
+            <a:off x="448056" y="2606040"/>
+            <a:ext cx="1097280" cy="1097280"/>
           </a:xfrm>
           <a:prstGeom prst="rect">
             <a:avLst/>
@@ -12040,14 +11945,206 @@
       </p:pic>
       <p:sp>
         <p:nvSpPr>
-          <p:cNvPr id="163" name="The code, the tests, and the plan behind them note"/>
+          <p:cNvPr id="161" name="Watch the demo note"/>
           <p:cNvSpPr txBox="1"/>
           <p:nvPr/>
         </p:nvSpPr>
         <p:spPr>
           <a:xfrm>
-            <a:off x="6208776" y="2606040"/>
-            <a:ext cx="2514600" cy="1325880"/>
+            <a:off x="1682496" y="2468880"/>
+            <a:ext cx="1463040" cy="1371600"/>
+          </a:xfrm>
+          <a:prstGeom prst="rect">
+            <a:avLst/>
+          </a:prstGeom>
+          <a:noFill/>
+        </p:spPr>
+        <p:txBody>
+          <a:bodyPr wrap="square" lIns="0" tIns="0" rIns="0" bIns="0" anchor="ctr">
+            <a:noAutofit/>
+          </a:bodyPr>
+          <a:lstStyle/>
+          <a:p>
+            <a:pPr algn="l" marL="0" indent="0">
+              <a:spcBef>
+                <a:spcPts val="0"/>
+              </a:spcBef>
+              <a:spcAft>
+                <a:spcPts val="400"/>
+              </a:spcAft>
+              <a:buNone/>
+            </a:pPr>
+            <a:r>
+              <a:rPr lang="en-GB" sz="1200" dirty="0">
+                <a:solidFill>
+                  <a:srgbClr val="202124"/>
+                </a:solidFill>
+                <a:latin typeface="Google Sans Flex SemiBold"/>
+                <a:ea typeface="Hiragino Sans"/>
+                <a:cs typeface="Google Sans Flex SemiBold"/>
+                <a:sym typeface="Google Sans Flex SemiBold"/>
+              </a:rPr>
+              <a:t>Watch the demo</a:t>
+            </a:r>
+          </a:p>
+          <a:p>
+            <a:pPr algn="l" marL="0" indent="0">
+              <a:lnSpc>
+                <a:spcPct val="105000"/>
+              </a:lnSpc>
+              <a:spcBef>
+                <a:spcPts val="0"/>
+              </a:spcBef>
+              <a:spcAft>
+                <a:spcPts val="0"/>
+              </a:spcAft>
+              <a:buNone/>
+            </a:pPr>
+            <a:r>
+              <a:rPr lang="en-GB" sz="1000" dirty="0">
+                <a:solidFill>
+                  <a:srgbClr val="5F6368"/>
+                </a:solidFill>
+                <a:latin typeface="Google Sans Flex"/>
+                <a:ea typeface="Hiragino Sans"/>
+                <a:cs typeface="Google Sans Flex"/>
+                <a:sym typeface="Google Sans Flex"/>
+              </a:rPr>
+              <a:t>3:48, in English: two conversations, the family page they made, and how to try it yourself.</a:t>
+            </a:r>
+          </a:p>
+        </p:txBody>
+      </p:sp>
+      <p:pic>
+        <p:nvPicPr>
+          <p:cNvPr id="162" name="Picture 161" descr="qr-product.png"/>
+          <p:cNvPicPr>
+            <a:picLocks noChangeAspect="1"/>
+          </p:cNvPicPr>
+          <p:nvPr/>
+        </p:nvPicPr>
+        <p:blipFill>
+          <a:blip r:embed="rId9"/>
+          <a:stretch>
+            <a:fillRect/>
+          </a:stretch>
+        </p:blipFill>
+        <p:spPr>
+          <a:xfrm>
+            <a:off x="3282696" y="2606040"/>
+            <a:ext cx="1097280" cy="1097280"/>
+          </a:xfrm>
+          <a:prstGeom prst="rect">
+            <a:avLst/>
+          </a:prstGeom>
+        </p:spPr>
+      </p:pic>
+      <p:sp>
+        <p:nvSpPr>
+          <p:cNvPr id="163" name="Try it on your own life note"/>
+          <p:cNvSpPr txBox="1"/>
+          <p:nvPr/>
+        </p:nvSpPr>
+        <p:spPr>
+          <a:xfrm>
+            <a:off x="4517136" y="2468880"/>
+            <a:ext cx="1463040" cy="1371600"/>
+          </a:xfrm>
+          <a:prstGeom prst="rect">
+            <a:avLst/>
+          </a:prstGeom>
+          <a:noFill/>
+        </p:spPr>
+        <p:txBody>
+          <a:bodyPr wrap="square" lIns="0" tIns="0" rIns="0" bIns="0" anchor="ctr">
+            <a:noAutofit/>
+          </a:bodyPr>
+          <a:lstStyle/>
+          <a:p>
+            <a:pPr algn="l" marL="0" indent="0">
+              <a:spcBef>
+                <a:spcPts val="0"/>
+              </a:spcBef>
+              <a:spcAft>
+                <a:spcPts val="400"/>
+              </a:spcAft>
+              <a:buNone/>
+            </a:pPr>
+            <a:r>
+              <a:rPr lang="en-GB" sz="1200" dirty="0">
+                <a:solidFill>
+                  <a:srgbClr val="202124"/>
+                </a:solidFill>
+                <a:latin typeface="Google Sans Flex SemiBold"/>
+                <a:ea typeface="Hiragino Sans"/>
+                <a:cs typeface="Google Sans Flex SemiBold"/>
+                <a:sym typeface="Google Sans Flex SemiBold"/>
+              </a:rPr>
+              <a:t>Try it on your own life</a:t>
+            </a:r>
+          </a:p>
+          <a:p>
+            <a:pPr algn="l" marL="0" indent="0">
+              <a:lnSpc>
+                <a:spcPct val="105000"/>
+              </a:lnSpc>
+              <a:spcBef>
+                <a:spcPts val="0"/>
+              </a:spcBef>
+              <a:spcAft>
+                <a:spcPts val="0"/>
+              </a:spcAft>
+              <a:buNone/>
+            </a:pPr>
+            <a:r>
+              <a:rPr lang="en-GB" sz="1000" dirty="0">
+                <a:solidFill>
+                  <a:srgbClr val="5F6368"/>
+                </a:solidFill>
+                <a:latin typeface="Google Sans Flex"/>
+                <a:ea typeface="Hiragino Sans"/>
+                <a:cs typeface="Google Sans Flex"/>
+                <a:sym typeface="Google Sans Flex"/>
+              </a:rPr>
+              <a:t>A family page from the demo, then a conversation of your own, in English. About three minutes.</a:t>
+            </a:r>
+          </a:p>
+        </p:txBody>
+      </p:sp>
+      <p:pic>
+        <p:nvPicPr>
+          <p:cNvPr id="164" name="Picture 163" descr="qr-repo.png"/>
+          <p:cNvPicPr>
+            <a:picLocks noChangeAspect="1"/>
+          </p:cNvPicPr>
+          <p:nvPr/>
+        </p:nvPicPr>
+        <p:blipFill>
+          <a:blip r:embed="rId10"/>
+          <a:stretch>
+            <a:fillRect/>
+          </a:stretch>
+        </p:blipFill>
+        <p:spPr>
+          <a:xfrm>
+            <a:off x="6117336" y="2606040"/>
+            <a:ext cx="1097280" cy="1097280"/>
+          </a:xfrm>
+          <a:prstGeom prst="rect">
+            <a:avLst/>
+          </a:prstGeom>
+        </p:spPr>
+      </p:pic>
+      <p:sp>
+        <p:nvSpPr>
+          <p:cNvPr id="165" name="The code, the tests, and the plan behind them note"/>
+          <p:cNvSpPr txBox="1"/>
+          <p:nvPr/>
+        </p:nvSpPr>
+        <p:spPr>
+          <a:xfrm>
+            <a:off x="7351776" y="2468880"/>
+            <a:ext cx="1463040" cy="1371600"/>
           </a:xfrm>
           <a:prstGeom prst="rect">
             <a:avLst/>
@@ -18635,7 +18732,7 @@
                 <a:cs typeface="Google Sans Flex Medium"/>
                 <a:sym typeface="Google Sans Flex Medium"/>
               </a:rPr>
-              <a:t>田中ハルさん</a:t>
+              <a:t>小川節子さん</a:t>
             </a:r>
           </a:p>
         </p:txBody>
@@ -18684,7 +18781,7 @@
                 <a:cs typeface="Google Sans Flex Medium"/>
                 <a:sym typeface="Google Sans Flex Medium"/>
               </a:rPr>
-              <a:t>ハルさん、こんにちは。学校のころのお話を、聞かせてください。</a:t>
+              <a:t>郡上おどり、いいですねえ。どなたと踊られたんですか。</a:t>
             </a:r>
           </a:p>
         </p:txBody>
@@ -19718,7 +19815,7 @@
                 <a:cs typeface="Google Sans Flex SemiBold"/>
                 <a:sym typeface="Google Sans Flex SemiBold"/>
               </a:rPr>
-              <a:t>Tanaka Haru</a:t>
+              <a:t>Ogawa Setsuko</a:t>
             </a:r>
           </a:p>
           <a:p>
@@ -19741,7 +19838,7 @@
                 <a:cs typeface="Google Sans Flex"/>
                 <a:sym typeface="Google Sans Flex"/>
               </a:rPr>
-              <a:t>田中ハル · Born in 1947, Nagano</a:t>
+              <a:t>小川節子 · Born in 1944, Gifu</a:t>
             </a:r>
           </a:p>
         </p:txBody>
@@ -19893,7 +19990,7 @@
                 <a:cs typeface="Google Sans Flex SemiBold"/>
                 <a:sym typeface="Google Sans Flex SemiBold"/>
               </a:rPr>
-              <a:t>CHAPTER 1 · CHILDHOOD</a:t>
+              <a:t>CHAPTER 2 · MARRIAGE</a:t>
             </a:r>
           </a:p>
         </p:txBody>
@@ -19942,7 +20039,7 @@
                 <a:cs typeface="Google Sans Flex SemiBold"/>
                 <a:sym typeface="Google Sans Flex SemiBold"/>
               </a:rPr>
-              <a:t>Her father's textile factory</a:t>
+              <a:t>Gujo Odori and Meeting Kazuo</a:t>
             </a:r>
           </a:p>
         </p:txBody>
@@ -19991,7 +20088,7 @@
                 <a:cs typeface="Google Sans Flex"/>
                 <a:sym typeface="Google Sans Flex"/>
               </a:rPr>
-              <a:t>Tanaka Haru grew up in a small mountain village in Nagano. Her father ran a small textile factory…</a:t>
+              <a:t>In the summer of Showa 40, when Setsuko was twenty-one, she met her husband Kazuo at the Gujo Odori…</a:t>
             </a:r>
           </a:p>
         </p:txBody>
@@ -20046,7 +20143,7 @@
                 <a:cs typeface="Google Sans Flex Medium"/>
                 <a:sym typeface="Google Sans Flex Medium"/>
               </a:rPr>
-              <a:t>All 3 quotes</a:t>
+              <a:t>All 2 quotes</a:t>
             </a:r>
           </a:p>
         </p:txBody>
@@ -20126,7 +20223,7 @@
                 <a:cs typeface="Google Sans Flex"/>
                 <a:sym typeface="Google Sans Flex"/>
               </a:rPr>
-              <a:t>「長野の、山あいの小さな村です。父は村で小さな織物の工場をやっておりました。」</a:t>
+              <a:t>「主人の和夫さんとはね、郡上おどりで知り合ったんですよ。…」</a:t>
             </a:r>
           </a:p>
           <a:p>
@@ -20152,7 +20249,7 @@
                 <a:cs typeface="Google Sans Flex"/>
                 <a:sym typeface="Google Sans Flex"/>
               </a:rPr>
-              <a:t>“It was a small village in Nagano…”</a:t>
+              <a:t>“I met my husband Kazuo…”</a:t>
             </a:r>
           </a:p>
         </p:txBody>

</xml_diff>

<commit_message>
Number the deck's mock-ups and architecture as the pictures are
- Wireframes: the senior's screen has three markers, and its notes now number
  three; the fourth, sharing or keeping the story, happens later on a screen of
  its own, so it follows as "Then, at the close". The family page's notes no
  longer number themselves a second time beside the phone's own markers, out of
  line with them: each sits beside its marker.
- Architecture: step 2 floated as a badge on the voice arrow, its label off to
  one side and "that token" pointing nowhere. It is now a step like the others,
  The conversation, on the voice's own path from the screen to Gemini, above
  Cloud Run, which it does not go through.

The PDF is exported from these by hand, so it follows separately.

Co-Authored-By: Claude Opus 5.5 <noreply@anthropic.com>
</commit_message>
<xml_diff>
--- a/docs/demo/kataribe-pitch-deck.pptx
+++ b/docs/demo/kataribe-pitch-deck.pptx
@@ -19594,51 +19594,46 @@
       </p:sp>
       <p:sp>
         <p:nvSpPr>
-          <p:cNvPr id="127" name="Oval 126"/>
-          <p:cNvSpPr/>
-          <p:nvPr/>
-        </p:nvSpPr>
-        <p:spPr>
-          <a:xfrm>
-            <a:off x="2551176" y="4608576"/>
-            <a:ext cx="201168" cy="201168"/>
-          </a:xfrm>
-          <a:prstGeom prst="ellipse">
-            <a:avLst/>
-          </a:prstGeom>
-          <a:solidFill>
-            <a:srgbClr val="D98F4E"/>
-          </a:solidFill>
-          <a:ln>
-            <a:noFill/>
-          </a:ln>
-        </p:spPr>
-        <p:txBody>
-          <a:bodyPr rtlCol="0" anchor="ctr" wrap="square" lIns="0" tIns="0" rIns="0" bIns="0">
+          <p:cNvPr id="127" name="Tablet then"/>
+          <p:cNvSpPr txBox="1"/>
+          <p:nvPr/>
+        </p:nvSpPr>
+        <p:spPr>
+          <a:xfrm>
+            <a:off x="2551176" y="4572000"/>
+            <a:ext cx="274320" cy="256032"/>
+          </a:xfrm>
+          <a:prstGeom prst="rect">
+            <a:avLst/>
+          </a:prstGeom>
+          <a:noFill/>
+        </p:spPr>
+        <p:txBody>
+          <a:bodyPr wrap="square" lIns="0" tIns="0" rIns="0" bIns="0" anchor="t">
             <a:noAutofit/>
           </a:bodyPr>
           <a:lstStyle/>
           <a:p>
-            <a:pPr algn="ctr" marL="0" indent="0">
-              <a:spcBef>
-                <a:spcPts val="0"/>
-              </a:spcBef>
-              <a:spcAft>
-                <a:spcPts val="0"/>
-              </a:spcAft>
-              <a:buNone/>
-            </a:pPr>
-            <a:r>
-              <a:rPr lang="en-GB" sz="1000" dirty="0">
-                <a:solidFill>
-                  <a:srgbClr val="1F1F1F"/>
+            <a:pPr algn="l" marL="0" indent="0">
+              <a:spcBef>
+                <a:spcPts val="0"/>
+              </a:spcBef>
+              <a:spcAft>
+                <a:spcPts val="0"/>
+              </a:spcAft>
+              <a:buNone/>
+            </a:pPr>
+            <a:r>
+              <a:rPr lang="en-GB" sz="1100" dirty="0">
+                <a:solidFill>
+                  <a:srgbClr val="A0561B"/>
                 </a:solidFill>
                 <a:latin typeface="Google Sans Flex SemiBold"/>
                 <a:ea typeface="Hiragino Sans"/>
                 <a:cs typeface="Google Sans Flex SemiBold"/>
                 <a:sym typeface="Google Sans Flex SemiBold"/>
               </a:rPr>
-              <a:t>4</a:t>
+              <a:t>→</a:t>
             </a:r>
           </a:p>
         </p:txBody>
@@ -19684,7 +19679,7 @@
                 <a:cs typeface="Google Sans Flex"/>
                 <a:sym typeface="Google Sans Flex"/>
               </a:rPr>
-              <a:t>Then: share today's story, or keep it</a:t>
+              <a:t>Then, at the close: share today's story, or keep it</a:t>
             </a:r>
           </a:p>
         </p:txBody>
@@ -20499,8 +20494,8 @@
         </p:nvSpPr>
         <p:spPr>
           <a:xfrm>
-            <a:off x="6967728" y="1325880"/>
-            <a:ext cx="1819656" cy="274320"/>
+            <a:off x="6903720" y="1325880"/>
+            <a:ext cx="1883664" cy="274320"/>
           </a:xfrm>
           <a:prstGeom prst="rect">
             <a:avLst/>
@@ -20539,65 +20534,14 @@
       </p:sp>
       <p:sp>
         <p:nvSpPr>
-          <p:cNvPr id="147" name="Oval 146"/>
-          <p:cNvSpPr/>
-          <p:nvPr/>
-        </p:nvSpPr>
-        <p:spPr>
-          <a:xfrm>
-            <a:off x="6967728" y="1755648"/>
-            <a:ext cx="201168" cy="201168"/>
-          </a:xfrm>
-          <a:prstGeom prst="ellipse">
-            <a:avLst/>
-          </a:prstGeom>
-          <a:solidFill>
-            <a:srgbClr val="D98F4E"/>
-          </a:solidFill>
-          <a:ln>
-            <a:noFill/>
-          </a:ln>
-        </p:spPr>
-        <p:txBody>
-          <a:bodyPr rtlCol="0" anchor="ctr" wrap="square" lIns="0" tIns="0" rIns="0" bIns="0">
-            <a:noAutofit/>
-          </a:bodyPr>
-          <a:lstStyle/>
-          <a:p>
-            <a:pPr algn="ctr" marL="0" indent="0">
-              <a:spcBef>
-                <a:spcPts val="0"/>
-              </a:spcBef>
-              <a:spcAft>
-                <a:spcPts val="0"/>
-              </a:spcAft>
-              <a:buNone/>
-            </a:pPr>
-            <a:r>
-              <a:rPr lang="en-GB" sz="1000" dirty="0">
-                <a:solidFill>
-                  <a:srgbClr val="1F1F1F"/>
-                </a:solidFill>
-                <a:latin typeface="Google Sans Flex SemiBold"/>
-                <a:ea typeface="Hiragino Sans"/>
-                <a:cs typeface="Google Sans Flex SemiBold"/>
-                <a:sym typeface="Google Sans Flex SemiBold"/>
-              </a:rPr>
-              <a:t>1</a:t>
-            </a:r>
-          </a:p>
-        </p:txBody>
-      </p:sp>
-      <p:sp>
-        <p:nvSpPr>
-          <p:cNvPr id="148" name="Family note 1"/>
+          <p:cNvPr id="147" name="Family note 1"/>
           <p:cNvSpPr txBox="1"/>
           <p:nvPr/>
         </p:nvSpPr>
         <p:spPr>
           <a:xfrm>
-            <a:off x="7242048" y="1737360"/>
-            <a:ext cx="1545336" cy="548640"/>
+            <a:off x="6903720" y="1764792"/>
+            <a:ext cx="1883664" cy="548640"/>
           </a:xfrm>
           <a:prstGeom prst="rect">
             <a:avLst/>
@@ -20639,65 +20583,14 @@
       </p:sp>
       <p:sp>
         <p:nvSpPr>
-          <p:cNvPr id="149" name="Oval 148"/>
-          <p:cNvSpPr/>
-          <p:nvPr/>
-        </p:nvSpPr>
-        <p:spPr>
-          <a:xfrm>
-            <a:off x="6967728" y="2359152"/>
-            <a:ext cx="201168" cy="201168"/>
-          </a:xfrm>
-          <a:prstGeom prst="ellipse">
-            <a:avLst/>
-          </a:prstGeom>
-          <a:solidFill>
-            <a:srgbClr val="D98F4E"/>
-          </a:solidFill>
-          <a:ln>
-            <a:noFill/>
-          </a:ln>
-        </p:spPr>
-        <p:txBody>
-          <a:bodyPr rtlCol="0" anchor="ctr" wrap="square" lIns="0" tIns="0" rIns="0" bIns="0">
-            <a:noAutofit/>
-          </a:bodyPr>
-          <a:lstStyle/>
-          <a:p>
-            <a:pPr algn="ctr" marL="0" indent="0">
-              <a:spcBef>
-                <a:spcPts val="0"/>
-              </a:spcBef>
-              <a:spcAft>
-                <a:spcPts val="0"/>
-              </a:spcAft>
-              <a:buNone/>
-            </a:pPr>
-            <a:r>
-              <a:rPr lang="en-GB" sz="1000" dirty="0">
-                <a:solidFill>
-                  <a:srgbClr val="1F1F1F"/>
-                </a:solidFill>
-                <a:latin typeface="Google Sans Flex SemiBold"/>
-                <a:ea typeface="Hiragino Sans"/>
-                <a:cs typeface="Google Sans Flex SemiBold"/>
-                <a:sym typeface="Google Sans Flex SemiBold"/>
-              </a:rPr>
-              <a:t>2</a:t>
-            </a:r>
-          </a:p>
-        </p:txBody>
-      </p:sp>
-      <p:sp>
-        <p:nvSpPr>
-          <p:cNvPr id="150" name="Family note 2"/>
+          <p:cNvPr id="148" name="Family note 2"/>
           <p:cNvSpPr txBox="1"/>
           <p:nvPr/>
         </p:nvSpPr>
         <p:spPr>
           <a:xfrm>
-            <a:off x="7242048" y="2340864"/>
-            <a:ext cx="1545336" cy="548640"/>
+            <a:off x="6903720" y="2194560"/>
+            <a:ext cx="1883664" cy="548640"/>
           </a:xfrm>
           <a:prstGeom prst="rect">
             <a:avLst/>
@@ -20739,65 +20632,14 @@
       </p:sp>
       <p:sp>
         <p:nvSpPr>
-          <p:cNvPr id="151" name="Oval 150"/>
-          <p:cNvSpPr/>
-          <p:nvPr/>
-        </p:nvSpPr>
-        <p:spPr>
-          <a:xfrm>
-            <a:off x="6967728" y="2962656"/>
-            <a:ext cx="201168" cy="201168"/>
-          </a:xfrm>
-          <a:prstGeom prst="ellipse">
-            <a:avLst/>
-          </a:prstGeom>
-          <a:solidFill>
-            <a:srgbClr val="D98F4E"/>
-          </a:solidFill>
-          <a:ln>
-            <a:noFill/>
-          </a:ln>
-        </p:spPr>
-        <p:txBody>
-          <a:bodyPr rtlCol="0" anchor="ctr" wrap="square" lIns="0" tIns="0" rIns="0" bIns="0">
-            <a:noAutofit/>
-          </a:bodyPr>
-          <a:lstStyle/>
-          <a:p>
-            <a:pPr algn="ctr" marL="0" indent="0">
-              <a:spcBef>
-                <a:spcPts val="0"/>
-              </a:spcBef>
-              <a:spcAft>
-                <a:spcPts val="0"/>
-              </a:spcAft>
-              <a:buNone/>
-            </a:pPr>
-            <a:r>
-              <a:rPr lang="en-GB" sz="1000" dirty="0">
-                <a:solidFill>
-                  <a:srgbClr val="1F1F1F"/>
-                </a:solidFill>
-                <a:latin typeface="Google Sans Flex SemiBold"/>
-                <a:ea typeface="Hiragino Sans"/>
-                <a:cs typeface="Google Sans Flex SemiBold"/>
-                <a:sym typeface="Google Sans Flex SemiBold"/>
-              </a:rPr>
-              <a:t>3</a:t>
-            </a:r>
-          </a:p>
-        </p:txBody>
-      </p:sp>
-      <p:sp>
-        <p:nvSpPr>
-          <p:cNvPr id="152" name="Family note 3"/>
+          <p:cNvPr id="149" name="Family note 3"/>
           <p:cNvSpPr txBox="1"/>
           <p:nvPr/>
         </p:nvSpPr>
         <p:spPr>
           <a:xfrm>
-            <a:off x="7242048" y="2944368"/>
-            <a:ext cx="1545336" cy="548640"/>
+            <a:off x="6903720" y="3794760"/>
+            <a:ext cx="1883664" cy="548640"/>
           </a:xfrm>
           <a:prstGeom prst="rect">
             <a:avLst/>
@@ -20839,14 +20681,14 @@
       </p:sp>
       <p:sp>
         <p:nvSpPr>
-          <p:cNvPr id="153" name="Status note"/>
+          <p:cNvPr id="150" name="Status note"/>
           <p:cNvSpPr txBox="1"/>
           <p:nvPr/>
         </p:nvSpPr>
         <p:spPr>
           <a:xfrm>
-            <a:off x="6967728" y="3657600"/>
-            <a:ext cx="1819656" cy="822960"/>
+            <a:off x="6903720" y="4361688"/>
+            <a:ext cx="1883664" cy="457200"/>
           </a:xfrm>
           <a:prstGeom prst="rect">
             <a:avLst/>
@@ -20881,7 +20723,7 @@
                 <a:cs typeface="Google Sans Flex"/>
                 <a:sym typeface="Google Sans Flex"/>
               </a:rPr>
-              <a:t>Both are built. kataribe.kaseovo.com shows a family page from the demo, and lets anyone try the conversation in English.</a:t>
+              <a:t>Both are live at kataribe.kaseovo.com, with this family page and a conversation to try in English.</a:t>
             </a:r>
           </a:p>
         </p:txBody>
@@ -22823,7 +22665,7 @@
         </p:nvCxnSpPr>
         <p:spPr>
           <a:xfrm>
-            <a:off x="2185416" y="1645920"/>
+            <a:off x="2185416" y="1600200"/>
             <a:ext cx="4352544" cy="0"/>
           </a:xfrm>
           <a:prstGeom prst="line">
@@ -22840,13 +22682,46 @@
       </p:cxnSp>
       <p:sp>
         <p:nvSpPr>
-          <p:cNvPr id="152" name="Oval 151"/>
+          <p:cNvPr id="152" name="The conversation"/>
           <p:cNvSpPr/>
           <p:nvPr/>
         </p:nvSpPr>
         <p:spPr>
           <a:xfrm>
-            <a:off x="4206240" y="1508760"/>
+            <a:off x="2926080" y="1353312"/>
+            <a:ext cx="2926080" cy="493776"/>
+          </a:xfrm>
+          <a:prstGeom prst="roundRect">
+            <a:avLst>
+              <a:gd name="adj" fmla="val 11111"/>
+            </a:avLst>
+          </a:prstGeom>
+          <a:solidFill>
+            <a:srgbClr val="FFFFFF"/>
+          </a:solidFill>
+          <a:ln w="9525">
+            <a:solidFill>
+              <a:srgbClr val="D98F4E"/>
+            </a:solidFill>
+          </a:ln>
+        </p:spPr>
+        <p:txBody>
+          <a:bodyPr rtlCol="0" anchor="ctr"/>
+          <a:lstStyle/>
+          <a:p>
+            <a:pPr algn="ctr"/>
+          </a:p>
+        </p:txBody>
+      </p:sp>
+      <p:sp>
+        <p:nvSpPr>
+          <p:cNvPr id="153" name="Oval 152"/>
+          <p:cNvSpPr/>
+          <p:nvPr/>
+        </p:nvSpPr>
+        <p:spPr>
+          <a:xfrm>
+            <a:off x="3017520" y="1463040"/>
             <a:ext cx="274320" cy="274320"/>
           </a:xfrm>
           <a:prstGeom prst="ellipse">
@@ -22891,14 +22766,14 @@
       </p:sp>
       <p:sp>
         <p:nvSpPr>
-          <p:cNvPr id="153" name="Voice label"/>
+          <p:cNvPr id="154" name="The conversation text"/>
           <p:cNvSpPr txBox="1"/>
           <p:nvPr/>
         </p:nvSpPr>
         <p:spPr>
           <a:xfrm>
-            <a:off x="4553712" y="1344168"/>
-            <a:ext cx="1965960" cy="274320"/>
+            <a:off x="3383280" y="1380744"/>
+            <a:ext cx="2423160" cy="438912"/>
           </a:xfrm>
           <a:prstGeom prst="rect">
             <a:avLst/>
@@ -22906,7 +22781,7 @@
           <a:noFill/>
         </p:spPr>
         <p:txBody>
-          <a:bodyPr wrap="square" lIns="0" tIns="0" rIns="0" bIns="0" anchor="t">
+          <a:bodyPr wrap="square" lIns="0" tIns="0" rIns="0" bIns="0" anchor="ctr">
             <a:noAutofit/>
           </a:bodyPr>
           <a:lstStyle/>
@@ -22916,28 +22791,54 @@
                 <a:spcPts val="0"/>
               </a:spcBef>
               <a:spcAft>
-                <a:spcPts val="0"/>
-              </a:spcAft>
-              <a:buNone/>
-            </a:pPr>
-            <a:r>
-              <a:rPr lang="en-GB" sz="900" dirty="0">
-                <a:solidFill>
-                  <a:srgbClr val="A0561B"/>
-                </a:solidFill>
-                <a:latin typeface="Google Sans Flex Medium"/>
+                <a:spcPts val="100"/>
+              </a:spcAft>
+              <a:buNone/>
+            </a:pPr>
+            <a:r>
+              <a:rPr lang="en-GB" sz="1000" dirty="0">
+                <a:solidFill>
+                  <a:srgbClr val="202124"/>
+                </a:solidFill>
+                <a:latin typeface="Google Sans Flex SemiBold"/>
                 <a:ea typeface="Hiragino Sans"/>
-                <a:cs typeface="Google Sans Flex Medium"/>
-                <a:sym typeface="Google Sans Flex Medium"/>
-              </a:rPr>
-              <a:t>Voice, both ways, with that token</a:t>
+                <a:cs typeface="Google Sans Flex SemiBold"/>
+                <a:sym typeface="Google Sans Flex SemiBold"/>
+              </a:rPr>
+              <a:t>The conversation</a:t>
+            </a:r>
+          </a:p>
+          <a:p>
+            <a:pPr algn="l" marL="0" indent="0">
+              <a:lnSpc>
+                <a:spcPct val="100000"/>
+              </a:lnSpc>
+              <a:spcBef>
+                <a:spcPts val="0"/>
+              </a:spcBef>
+              <a:spcAft>
+                <a:spcPts val="0"/>
+              </a:spcAft>
+              <a:buNone/>
+            </a:pPr>
+            <a:r>
+              <a:rPr lang="en-GB" sz="850" dirty="0">
+                <a:solidFill>
+                  <a:srgbClr val="5F6368"/>
+                </a:solidFill>
+                <a:latin typeface="Google Sans Flex"/>
+                <a:ea typeface="Hiragino Sans"/>
+                <a:cs typeface="Google Sans Flex"/>
+                <a:sym typeface="Google Sans Flex"/>
+              </a:rPr>
+              <a:t>Voice both ways, screen to Gemini, on the token from 1</a:t>
             </a:r>
           </a:p>
         </p:txBody>
       </p:sp>
       <p:cxnSp>
         <p:nvCxnSpPr>
-          <p:cNvPr id="154" name="Connector 153"/>
+          <p:cNvPr id="155" name="Connector 154"/>
           <p:cNvCxnSpPr/>
           <p:nvPr/>
         </p:nvCxnSpPr>
@@ -22960,7 +22861,7 @@
       </p:cxnSp>
       <p:cxnSp>
         <p:nvCxnSpPr>
-          <p:cNvPr id="155" name="Connector 154"/>
+          <p:cNvPr id="156" name="Connector 155"/>
           <p:cNvCxnSpPr/>
           <p:nvPr/>
         </p:nvCxnSpPr>
@@ -22982,7 +22883,7 @@
       </p:cxnSp>
       <p:cxnSp>
         <p:nvCxnSpPr>
-          <p:cNvPr id="156" name="Connector 155"/>
+          <p:cNvPr id="157" name="Connector 156"/>
           <p:cNvCxnSpPr/>
           <p:nvPr/>
         </p:nvCxnSpPr>
@@ -23005,7 +22906,7 @@
       </p:cxnSp>
       <p:cxnSp>
         <p:nvCxnSpPr>
-          <p:cNvPr id="157" name="Connector 156"/>
+          <p:cNvPr id="158" name="Connector 157"/>
           <p:cNvCxnSpPr/>
           <p:nvPr/>
         </p:nvCxnSpPr>
@@ -23028,7 +22929,7 @@
       </p:cxnSp>
       <p:cxnSp>
         <p:nvCxnSpPr>
-          <p:cNvPr id="158" name="Connector 157"/>
+          <p:cNvPr id="159" name="Connector 158"/>
           <p:cNvCxnSpPr/>
           <p:nvPr/>
         </p:nvCxnSpPr>
@@ -23051,7 +22952,7 @@
       </p:cxnSp>
       <p:cxnSp>
         <p:nvCxnSpPr>
-          <p:cNvPr id="159" name="Connector 158"/>
+          <p:cNvPr id="160" name="Connector 159"/>
           <p:cNvCxnSpPr/>
           <p:nvPr/>
         </p:nvCxnSpPr>

</xml_diff>